<commit_message>
Correct HYP-MOM-02.1 to fresh SMA200 crosses
</commit_message>
<xml_diff>
--- a/operator_hypothesis_lab/presentations/hyp_mom_02_1_sma200_cross_wide_discovery_evidence.pptx
+++ b/operator_hypothesis_lab/presentations/hyp_mom_02_1_sma200_cross_wide_discovery_evidence.pptx
@@ -2,30 +2,30 @@
 <file path=ppt/presentation.xml><?xml version="1.0" encoding="utf-8"?>
 <p:presentation xmlns:p="http://schemas.openxmlformats.org/presentationml/2006/main">
   <p:sldMasterIdLst>
-    <p:sldMasterId xmlns:r="http://schemas.openxmlformats.org/officeDocument/2006/relationships" id="2147483648" r:id="R5d601f1046cb46b9"/>
+    <p:sldMasterId xmlns:r="http://schemas.openxmlformats.org/officeDocument/2006/relationships" id="2147483648" r:id="Rb86c43ce828c48e0"/>
   </p:sldMasterIdLst>
   <p:notesMasterIdLst>
-    <p:notesMasterId xmlns:r="http://schemas.openxmlformats.org/officeDocument/2006/relationships" r:id="R0e5c78d638cc4086"/>
+    <p:notesMasterId xmlns:r="http://schemas.openxmlformats.org/officeDocument/2006/relationships" r:id="Rcb0b0318ec85483f"/>
   </p:notesMasterIdLst>
   <p:sldIdLst>
-    <p:sldId xmlns:r="http://schemas.openxmlformats.org/officeDocument/2006/relationships" id="256" r:id="Re48daee387964eb4"/>
-    <p:sldId xmlns:r="http://schemas.openxmlformats.org/officeDocument/2006/relationships" id="257" r:id="Rf144b341476c44a9"/>
-    <p:sldId xmlns:r="http://schemas.openxmlformats.org/officeDocument/2006/relationships" id="258" r:id="R649fdf25139440a7"/>
-    <p:sldId xmlns:r="http://schemas.openxmlformats.org/officeDocument/2006/relationships" id="259" r:id="R50ed35f4378a45f6"/>
-    <p:sldId xmlns:r="http://schemas.openxmlformats.org/officeDocument/2006/relationships" id="260" r:id="Ra413532f5ec846e4"/>
-    <p:sldId xmlns:r="http://schemas.openxmlformats.org/officeDocument/2006/relationships" id="261" r:id="Rb62e354e0f1a43e9"/>
-    <p:sldId xmlns:r="http://schemas.openxmlformats.org/officeDocument/2006/relationships" id="262" r:id="Rbff16c94c599419f"/>
-    <p:sldId xmlns:r="http://schemas.openxmlformats.org/officeDocument/2006/relationships" id="263" r:id="Ra1a2262bc51d45b3"/>
-    <p:sldId xmlns:r="http://schemas.openxmlformats.org/officeDocument/2006/relationships" id="264" r:id="R602bd826e13b4c0d"/>
-    <p:sldId xmlns:r="http://schemas.openxmlformats.org/officeDocument/2006/relationships" id="265" r:id="R2c50709b429940ed"/>
-    <p:sldId xmlns:r="http://schemas.openxmlformats.org/officeDocument/2006/relationships" id="266" r:id="Re726c227608f40cd"/>
-    <p:sldId xmlns:r="http://schemas.openxmlformats.org/officeDocument/2006/relationships" id="267" r:id="R04969df2e1344cab"/>
-    <p:sldId xmlns:r="http://schemas.openxmlformats.org/officeDocument/2006/relationships" id="268" r:id="Rd2e7a9331c2c456c"/>
-    <p:sldId xmlns:r="http://schemas.openxmlformats.org/officeDocument/2006/relationships" id="269" r:id="Rc5fba628b8254697"/>
-    <p:sldId xmlns:r="http://schemas.openxmlformats.org/officeDocument/2006/relationships" id="270" r:id="R6d8aa32ecc40446c"/>
-    <p:sldId xmlns:r="http://schemas.openxmlformats.org/officeDocument/2006/relationships" id="271" r:id="R2e743a8500a44e97"/>
-    <p:sldId xmlns:r="http://schemas.openxmlformats.org/officeDocument/2006/relationships" id="272" r:id="R99bc98b72f9d4c7a"/>
-    <p:sldId xmlns:r="http://schemas.openxmlformats.org/officeDocument/2006/relationships" id="273" r:id="R6a321ea00bd44391"/>
+    <p:sldId xmlns:r="http://schemas.openxmlformats.org/officeDocument/2006/relationships" id="256" r:id="R2e60ea4c02194508"/>
+    <p:sldId xmlns:r="http://schemas.openxmlformats.org/officeDocument/2006/relationships" id="257" r:id="R35d70f6d24e846ef"/>
+    <p:sldId xmlns:r="http://schemas.openxmlformats.org/officeDocument/2006/relationships" id="258" r:id="Re0f104ca932c4c49"/>
+    <p:sldId xmlns:r="http://schemas.openxmlformats.org/officeDocument/2006/relationships" id="259" r:id="R15787070ce6f48a9"/>
+    <p:sldId xmlns:r="http://schemas.openxmlformats.org/officeDocument/2006/relationships" id="260" r:id="Rfc86a593a4744037"/>
+    <p:sldId xmlns:r="http://schemas.openxmlformats.org/officeDocument/2006/relationships" id="261" r:id="R5c360e59dfa04e4e"/>
+    <p:sldId xmlns:r="http://schemas.openxmlformats.org/officeDocument/2006/relationships" id="262" r:id="R32277df9c21d4e7c"/>
+    <p:sldId xmlns:r="http://schemas.openxmlformats.org/officeDocument/2006/relationships" id="263" r:id="Rc94030e40a804938"/>
+    <p:sldId xmlns:r="http://schemas.openxmlformats.org/officeDocument/2006/relationships" id="264" r:id="R95badff4363c46ed"/>
+    <p:sldId xmlns:r="http://schemas.openxmlformats.org/officeDocument/2006/relationships" id="265" r:id="R85a3037c98f2472b"/>
+    <p:sldId xmlns:r="http://schemas.openxmlformats.org/officeDocument/2006/relationships" id="266" r:id="R08d7efae9f17403f"/>
+    <p:sldId xmlns:r="http://schemas.openxmlformats.org/officeDocument/2006/relationships" id="267" r:id="Rd28e323137da4aa5"/>
+    <p:sldId xmlns:r="http://schemas.openxmlformats.org/officeDocument/2006/relationships" id="268" r:id="R2d748a2a1b8d4426"/>
+    <p:sldId xmlns:r="http://schemas.openxmlformats.org/officeDocument/2006/relationships" id="269" r:id="R7c70feffba4d4ba6"/>
+    <p:sldId xmlns:r="http://schemas.openxmlformats.org/officeDocument/2006/relationships" id="270" r:id="Rb492049b55b64c33"/>
+    <p:sldId xmlns:r="http://schemas.openxmlformats.org/officeDocument/2006/relationships" id="271" r:id="Ra8be76a588ac4de2"/>
+    <p:sldId xmlns:r="http://schemas.openxmlformats.org/officeDocument/2006/relationships" id="272" r:id="R4b2b23b967c54e9f"/>
+    <p:sldId xmlns:r="http://schemas.openxmlformats.org/officeDocument/2006/relationships" id="273" r:id="Re9614b0bac974d9f"/>
   </p:sldIdLst>
   <p:sldSz cx="12192000" cy="6858000"/>
   <p:notesSz cx="6858000" cy="9144000"/>
@@ -459,7 +459,7 @@
           <a:lstStyle xmlns:a="http://schemas.openxmlformats.org/drawingml/2006/main"/>
           <a:p xmlns:a="http://schemas.openxmlformats.org/drawingml/2006/main">
             <a:r>
-              <a:t>This deck answers a deliberately simple question across a wide frozen panel. The causal next-open SMA200 rule reduced drawdowns more broadly than it improved returns. Its cost was substantial upside capture loss and frequent whipsaw.</a:t>
+              <a:t>This corrected deck begins every asset in cash and admits only fresh in-window crosses. Removing warm starts materially lowered exposure and return, while strengthening the drawdown-defense interpretation.</a:t>
             </a:r>
           </a:p>
           <a:p xmlns:a="http://schemas.openxmlformats.org/drawingml/2006/main">
@@ -549,7 +549,7 @@
           <a:lstStyle xmlns:a="http://schemas.openxmlformats.org/drawingml/2006/main"/>
           <a:p xmlns:a="http://schemas.openxmlformats.org/drawingml/2006/main">
             <a:r>
-              <a:t>The retail-attention cohort illustrates protection rather than success: the median strategy still lost 22.3%, but less than continuous ownership. Energy illustrates the opposite cost: the filter captured only part of a powerful rally. Cohorts and sectors were not randomized and cannot be promoted as filters.</a:t>
+              <a:t>The attention cohort illustrates protection rather than success: median strategy return was -18.7%, but less negative than ownership. Energy illustrates foregone upside: median strategy return was about +25% versus +167% ownership. Neither view authorizes selection.</a:t>
             </a:r>
           </a:p>
           <a:p xmlns:a="http://schemas.openxmlformats.org/drawingml/2006/main">
@@ -644,7 +644,7 @@
           <a:lstStyle xmlns:a="http://schemas.openxmlformats.org/drawingml/2006/main"/>
           <a:p xmlns:a="http://schemas.openxmlformats.org/drawingml/2006/main">
             <a:r>
-              <a:t>The six archetypes were frozen in the contract: median excess, highest excess, lowest excess, best drawdown improvement, highest trade count, and longest median holding duration. They are audit examples, not candidate assets.</a:t>
+              <a:t>The six archetype roles remain exactly as frozen. The corrected outcomes cause CGC to occupy both highest-excess and best-drawdown roles, while MPC occupies both lowest-excess and longest-hold roles. Duplicates are retained transparently rather than replaced after inspection.</a:t>
             </a:r>
           </a:p>
           <a:p xmlns:a="http://schemas.openxmlformats.org/drawingml/2006/main">
@@ -734,7 +734,7 @@
           <a:lstStyle xmlns:a="http://schemas.openxmlformats.org/drawingml/2006/main"/>
           <a:p xmlns:a="http://schemas.openxmlformats.org/drawingml/2006/main">
             <a:r>
-              <a:t>CL returned -19.1% under the strategy versus approximately flat ownership. The repeated green state segments show that a slow filter can still churn around the anchor and lose both absolute and relative value.</a:t>
+              <a:t>AEP is the corrected median-excess asset. The strategy lost 13.4% while ownership gained 8.3%, a 21.8-point relative shortfall despite modest drawdown improvement.</a:t>
             </a:r>
           </a:p>
           <a:p xmlns:a="http://schemas.openxmlformats.org/drawingml/2006/main">
@@ -824,7 +824,7 @@
           <a:lstStyle xmlns:a="http://schemas.openxmlformats.org/drawingml/2006/main"/>
           <a:p xmlns:a="http://schemas.openxmlformats.org/drawingml/2006/main">
             <a:r>
-              <a:t>CGC's strategy loss was -15.2% versus -97.9% for ownership, producing the highest excess return. This is dramatic protection, not a profitable trade path. Relative and absolute success must remain separate.</a:t>
+              <a:t>CGC's corrected strategy loss was -16.4% versus -97.9% ownership. It is both the highest-excess and best-drawdown-improvement asset. That is dramatic protection, not a profitable strategy path.</a:t>
             </a:r>
           </a:p>
           <a:p xmlns:a="http://schemas.openxmlformats.org/drawingml/2006/main">
@@ -914,7 +914,7 @@
           <a:lstStyle xmlns:a="http://schemas.openxmlformats.org/drawingml/2006/main"/>
           <a:p xmlns:a="http://schemas.openxmlformats.org/drawingml/2006/main">
             <a:r>
-              <a:t>CPRX gained 173.9% under the strategy, but ownership gained 416.0%. The filter exited and re-entered during a powerful trend, missing about 242 percentage points. A positive strategy return is not evidence of value-add.</a:t>
+              <a:t>MPC gained 23.1% under the cross-only rule, but ownership gained 286.8%. Waiting for the first fresh cross left the strategy in cash through most of the exceptional trend.</a:t>
             </a:r>
           </a:p>
           <a:p xmlns:a="http://schemas.openxmlformats.org/drawingml/2006/main">
@@ -1004,7 +1004,7 @@
           <a:lstStyle xmlns:a="http://schemas.openxmlformats.org/drawingml/2006/main"/>
           <a:p xmlns:a="http://schemas.openxmlformats.org/drawingml/2006/main">
             <a:r>
-              <a:t>META gained 89.7% under the filter versus 30.7% for ownership, while avoiding much of the 2022 collapse. It is the strongest drawdown-improvement archetype, but one favorable asset does not authorize selection.</a:t>
+              <a:t>CGC legitimately repeats because it also has the greatest drawdown improvement. The duplicate is evidence about the frozen selection rules, not a second independent success case.</a:t>
             </a:r>
           </a:p>
           <a:p xmlns:a="http://schemas.openxmlformats.org/drawingml/2006/main">
@@ -1094,7 +1094,7 @@
           <a:lstStyle xmlns:a="http://schemas.openxmlformats.org/drawingml/2006/main"/>
           <a:p xmlns:a="http://schemas.openxmlformats.org/drawingml/2006/main">
             <a:r>
-              <a:t>VZ generated the most round trips. Strategy and ownership both lost about 25%, while strategy drawdown was slightly worse. The rule's simple mechanics do not guarantee useful risk reduction when price oscillates near the anchor.</a:t>
+              <a:t>VZ generated 26 round trips, the most in the panel. The strategy lost 22.7% versus -25.1% ownership and reduced drawdown, but frequent crossings still failed to produce a profitable path.</a:t>
             </a:r>
           </a:p>
           <a:p xmlns:a="http://schemas.openxmlformats.org/drawingml/2006/main">
@@ -1184,7 +1184,7 @@
           <a:lstStyle xmlns:a="http://schemas.openxmlformats.org/drawingml/2006/main"/>
           <a:p xmlns:a="http://schemas.openxmlformats.org/drawingml/2006/main">
             <a:r>
-              <a:t>JPM's long-lived states produced 65.3% versus 45.8% ownership with a smaller maximum drawdown. This is the behavior the rule seeks, but the wide panel shows it is not the typical relative outcome.</a:t>
+              <a:t>MPC legitimately repeats because its two trades had the longest median holding duration. It is also the worst relative result, showing that a long hold is useful only when it captures enough of the trend.</a:t>
             </a:r>
           </a:p>
           <a:p xmlns:a="http://schemas.openxmlformats.org/drawingml/2006/main">
@@ -1274,7 +1274,7 @@
           <a:lstStyle xmlns:a="http://schemas.openxmlformats.org/drawingml/2006/main"/>
           <a:p xmlns:a="http://schemas.openxmlformats.org/drawingml/2006/main">
             <a:r>
-              <a:t>Record WIDE_DISCOVERY_COMPLETE_NO_PROMOTION_AUTHORITY. The experiment is successful as an educational POC: it shows exactly what this classic rule bought and what it cost. Do not tune the average, add a buffer, select favorable sectors, or promote the attention cohort from this reused discovery packet.</a:t>
+              <a:t>Record WIDE_DISCOVERY_COMPLETE_NO_PROMOTION_AUTHORITY with CROSS_TRIGGERED_ONLY_NO_WARM_START as authoritative. Fresh crosses did not demonstrate generic timing value. Do not tune the average, add buffers, select favorable groups, or inspect 2024+ from this reused discovery result.</a:t>
             </a:r>
           </a:p>
           <a:p xmlns:a="http://schemas.openxmlformats.org/drawingml/2006/main">
@@ -1374,7 +1374,7 @@
           <a:lstStyle xmlns:a="http://schemas.openxmlformats.org/drawingml/2006/main"/>
           <a:p xmlns:a="http://schemas.openxmlformats.org/drawingml/2006/main">
             <a:r>
-              <a:t>The rule uses only a completed adjusted close and its contemporaneous 200-session simple average. Orders occur at the following open. Warm-start and final liquidation rules prevent the arbitrary evaluation boundary from manufacturing or suppressing exposure.</a:t>
+              <a:t>The SMA uses 200 completed adjusted closes. A cross above completed after the discovery window begins triggers entry at the following open; a cross below triggers exit at the following open. Being above at the boundary is ignored, so no warm-start trade remains.</a:t>
             </a:r>
           </a:p>
           <a:p xmlns:a="http://schemas.openxmlformats.org/drawingml/2006/main">
@@ -1459,7 +1459,7 @@
           <a:lstStyle xmlns:a="http://schemas.openxmlformats.org/drawingml/2006/main"/>
           <a:p xmlns:a="http://schemas.openxmlformats.org/drawingml/2006/main">
             <a:r>
-              <a:t>SMA200 is a lagging state rule. It trades responsiveness for noise reduction. The relevant question is not whether every cross predicts the next return, but whether the full long/cash path offers a worthwhile exchange among return, drawdown, exposure, and whipsaw.</a:t>
+              <a:t>SMA200 is a lagging trigger. The corrected question is not whether every above-SMA state earns a return, but whether trades begun by fresh crosses create a worthwhile return, drawdown, exposure, and whipsaw exchange.</a:t>
             </a:r>
           </a:p>
           <a:p xmlns:a="http://schemas.openxmlformats.org/drawingml/2006/main">
@@ -1644,7 +1644,7 @@
           <a:lstStyle xmlns:a="http://schemas.openxmlformats.org/drawingml/2006/main"/>
           <a:p xmlns:a="http://schemas.openxmlformats.org/drawingml/2006/main">
             <a:r>
-              <a:t>The wide result is a return-versus-protection tradeoff. The median strategy gained 6.24%, but the median stock gained 20.79% under buy-and-hold. Maximum drawdown improved in 79 assets, while only 30 beat ownership. Lower risk was much broader than better return.</a:t>
+              <a:t>The cross-only result is more defensive and less profitable than the warm-start readout. Median strategy return was -2.73% versus +20.79% ownership. Drawdown improved in 88 assets, but only 26 beat ownership.</a:t>
             </a:r>
           </a:p>
           <a:p xmlns:a="http://schemas.openxmlformats.org/drawingml/2006/main">
@@ -1739,7 +1739,7 @@
           <a:lstStyle xmlns:a="http://schemas.openxmlformats.org/drawingml/2006/main"/>
           <a:p xmlns:a="http://schemas.openxmlformats.org/drawingml/2006/main">
             <a:r>
-              <a:t>The left panel compares full-window returns with the diagonal marking equality. The right compares maximum drawdowns; points above the diagonal are less negative and therefore improved. Only 30 assets beat buy-and-hold, while 79 reduced maximum drawdown.</a:t>
+              <a:t>The left panel compares full-window returns; the right compares maximum drawdowns. Only 26 assets beat buy-and-hold, while 88 reduced maximum drawdown. All 26 return winners also improved drawdown.</a:t>
             </a:r>
           </a:p>
           <a:p xmlns:a="http://schemas.openxmlformats.org/drawingml/2006/main">
@@ -1829,7 +1829,7 @@
           <a:lstStyle xmlns:a="http://schemas.openxmlformats.org/drawingml/2006/main"/>
           <a:p xmlns:a="http://schemas.openxmlformats.org/drawingml/2006/main">
             <a:r>
-              <a:t>Every point is one asset. The upper-right quadrant improves both return and maximum drawdown and contains 30 assets. Many more points sit upper-left: the rule reduced drawdown but lagged ownership. Point size reflects exposure fraction.</a:t>
+              <a:t>Every point is one asset. The upper-right quadrant contains 26 assets that improved both return and maximum drawdown. Another 62 reduced drawdown while still lagging ownership. Point size reflects corrected cross-only exposure.</a:t>
             </a:r>
           </a:p>
           <a:p xmlns:a="http://schemas.openxmlformats.org/drawingml/2006/main">
@@ -1919,7 +1919,7 @@
           <a:lstStyle xmlns:a="http://schemas.openxmlformats.org/drawingml/2006/main"/>
           <a:p xmlns:a="http://schemas.openxmlformats.org/drawingml/2006/main">
             <a:r>
-              <a:t>The trade distribution is convex. Price repeatedly crosses a lagging average, producing many short losing trades. A small minority of long-lived winners lifts the mean above zero even though the median trade is negative and only 25% win. Hit rate is therefore a poor standalone score for this strategy family.</a:t>
+              <a:t>The observed trade distribution is right-skewed: the median trade lost 1.35%, while a smaller set of longer winners lifted the mean to only +0.15%. In mathematics, convexity means increasing payoff slope, or positive second derivative where defined. This run demonstrates asymmetric right-skewed outcomes; it does not formally estimate payoff curvature.</a:t>
             </a:r>
           </a:p>
           <a:p xmlns:a="http://schemas.openxmlformats.org/drawingml/2006/main">
@@ -2014,7 +2014,7 @@
           <a:lstStyle xmlns:a="http://schemas.openxmlformats.org/drawingml/2006/main"/>
           <a:p xmlns:a="http://schemas.openxmlformats.org/drawingml/2006/main">
             <a:r>
-              <a:t>Each of 500 circular shifts preserves the asset's exposure fraction and serial block structure while changing alignment with returns. The median observed percentile is 33.8%; only 36 assets exceed the median shift and only MMM and GE exceed the 80th percentile. Shifted states are diagnostics, not executable strategies or independent p-values.</a:t>
+              <a:t>Each circular shift preserves the corrected cross-triggered exposure fraction and serial block structure. The median observed percentile is 27.4%; 34 assets exceed the median shift, while ADBE, CHTR, and GE exceed the 80th percentile. These are diagnostics, not executable strategies or p-values.</a:t>
             </a:r>
           </a:p>
           <a:p xmlns:a="http://schemas.openxmlformats.org/drawingml/2006/main">
@@ -2107,7 +2107,7 @@
   </p:cSld>
   <p:clrMap bg1="lt1" tx1="dk1" bg2="lt2" tx2="dk2" accent1="accent1" accent2="accent2" accent3="accent3" accent4="accent4" accent5="accent5" accent6="accent6" hlink="hlink" folHlink="folHlink"/>
   <p:sldLayoutIdLst>
-    <p:sldLayoutId xmlns:r="http://schemas.openxmlformats.org/officeDocument/2006/relationships" id="2147483649" r:id="R1d39c4469db848e2"/>
+    <p:sldLayoutId xmlns:r="http://schemas.openxmlformats.org/officeDocument/2006/relationships" id="2147483649" r:id="R40dce56403d24749"/>
   </p:sldLayoutIdLst>
   <p:txStyles>
     <p:titleStyle>
@@ -2688,6 +2688,7 @@
           <a:lstStyle xmlns:a="http://schemas.openxmlformats.org/drawingml/2006/main"/>
           <a:p xmlns:a="http://schemas.openxmlformats.org/drawingml/2006/main">
             <a:pPr algn="l">
+              <a:buNone/>
               <a:defRPr sz="2100" b="0">
                 <a:solidFill>
                   <a:srgbClr val="667085"/>
@@ -2746,6 +2747,7 @@
           <a:lstStyle xmlns:a="http://schemas.openxmlformats.org/drawingml/2006/main"/>
           <a:p xmlns:a="http://schemas.openxmlformats.org/drawingml/2006/main">
             <a:pPr algn="l">
+              <a:buNone/>
               <a:defRPr sz="6150" b="0">
                 <a:solidFill>
                   <a:srgbClr val="000000"/>
@@ -2764,11 +2766,12 @@
                 <a:ea typeface="Helvetica Neue"/>
                 <a:cs typeface="Helvetica Neue"/>
               </a:rPr>
-              <a:t>Protection,</a:t>
+              <a:t>Fresh crosses,</a:t>
             </a:r>
           </a:p>
           <a:p xmlns:a="http://schemas.openxmlformats.org/drawingml/2006/main">
             <a:pPr algn="l">
+              <a:buNone/>
               <a:defRPr sz="6150" b="0">
                 <a:solidFill>
                   <a:srgbClr val="000000"/>
@@ -2827,6 +2830,7 @@
           <a:lstStyle xmlns:a="http://schemas.openxmlformats.org/drawingml/2006/main"/>
           <a:p xmlns:a="http://schemas.openxmlformats.org/drawingml/2006/main">
             <a:pPr algn="l">
+              <a:buNone/>
               <a:defRPr sz="2175" b="0">
                 <a:solidFill>
                   <a:srgbClr val="000000"/>
@@ -2845,7 +2849,7 @@
                 <a:ea typeface="Helvetica Neue"/>
                 <a:cs typeface="Helvetica Neue"/>
               </a:rPr>
-              <a:t>What happened when 119 stocks crossed their 200-session average?</a:t>
+              <a:t>What happened when 119 stocks waited for a new SMA200 cross?</a:t>
             </a:r>
           </a:p>
         </p:txBody>
@@ -2907,6 +2911,7 @@
           <a:lstStyle xmlns:a="http://schemas.openxmlformats.org/drawingml/2006/main"/>
           <a:p xmlns:a="http://schemas.openxmlformats.org/drawingml/2006/main">
             <a:pPr algn="l">
+              <a:buNone/>
               <a:defRPr sz="2903" b="0">
                 <a:solidFill>
                   <a:srgbClr val="000000"/>
@@ -2965,6 +2970,7 @@
           <a:lstStyle xmlns:a="http://schemas.openxmlformats.org/drawingml/2006/main"/>
           <a:p xmlns:a="http://schemas.openxmlformats.org/drawingml/2006/main">
             <a:pPr algn="r">
+              <a:buNone/>
               <a:defRPr sz="998" b="0">
                 <a:solidFill>
                   <a:srgbClr val="000000"/>
@@ -2990,18 +2996,18 @@
       </p:sp>
       <p:pic>
         <p:nvPicPr>
-          <p:cNvPr id="11" name=""/>
+          <p:cNvPr id="13" name=""/>
           <p:cNvPicPr>
             <a:picLocks xmlns:a="http://schemas.openxmlformats.org/drawingml/2006/main" noChangeAspect="1"/>
           </p:cNvPicPr>
           <p:nvPr/>
         </p:nvPicPr>
         <p:blipFill>
-          <a:blip xmlns:r="http://schemas.openxmlformats.org/officeDocument/2006/relationships" xmlns:a="http://schemas.openxmlformats.org/drawingml/2006/main" r:embed="Rb36697c009bb4fb5"/>
+          <a:blip xmlns:r="http://schemas.openxmlformats.org/officeDocument/2006/relationships" xmlns:a="http://schemas.openxmlformats.org/drawingml/2006/main" r:embed="Rb78ead3923c84b2d"/>
           <a:stretch xmlns:a="http://schemas.openxmlformats.org/drawingml/2006/main"/>
         </p:blipFill>
         <p:spPr>
-          <a:xfrm xmlns:a="http://schemas.openxmlformats.org/drawingml/2006/main">
+          <a:xfrm xmlns:a="http://schemas.openxmlformats.org/drawingml/2006/main" flipH="0" flipV="0">
             <a:off x="390525" y="1465792"/>
             <a:ext cx="7239000" cy="4021667"/>
           </a:xfrm>
@@ -3045,6 +3051,7 @@
           <a:lstStyle xmlns:a="http://schemas.openxmlformats.org/drawingml/2006/main"/>
           <a:p xmlns:a="http://schemas.openxmlformats.org/drawingml/2006/main">
             <a:pPr algn="ctr">
+              <a:buNone/>
               <a:defRPr sz="1650" b="1">
                 <a:solidFill>
                   <a:srgbClr val="3D8DFF"/>
@@ -3103,6 +3110,7 @@
           <a:lstStyle xmlns:a="http://schemas.openxmlformats.org/drawingml/2006/main"/>
           <a:p xmlns:a="http://schemas.openxmlformats.org/drawingml/2006/main">
             <a:pPr algn="ctr">
+              <a:buNone/>
               <a:defRPr sz="1875" b="0">
                 <a:solidFill>
                   <a:srgbClr val="000000"/>
@@ -3121,11 +3129,12 @@
                 <a:ea typeface="Helvetica Neue"/>
                 <a:cs typeface="Helvetica Neue"/>
               </a:rPr>
-              <a:t>-22.3% strategy</a:t>
+              <a:t>-18.7% strategy</a:t>
             </a:r>
           </a:p>
           <a:p xmlns:a="http://schemas.openxmlformats.org/drawingml/2006/main">
             <a:pPr algn="ctr">
+              <a:buNone/>
               <a:defRPr sz="1875" b="0">
                 <a:solidFill>
                   <a:srgbClr val="000000"/>
@@ -3149,6 +3158,7 @@
           </a:p>
           <a:p xmlns:a="http://schemas.openxmlformats.org/drawingml/2006/main">
             <a:pPr algn="ctr">
+              <a:buNone/>
               <a:defRPr sz="1875" b="0">
                 <a:solidFill>
                   <a:srgbClr val="000000"/>
@@ -3167,7 +3177,7 @@
                 <a:ea typeface="Helvetica Neue"/>
                 <a:cs typeface="Helvetica Neue"/>
               </a:rPr>
-              <a:t>+21.8 pp median DD improvement</a:t>
+              <a:t>+27.9 pp median DD improvement</a:t>
             </a:r>
           </a:p>
         </p:txBody>
@@ -3207,6 +3217,7 @@
           <a:lstStyle xmlns:a="http://schemas.openxmlformats.org/drawingml/2006/main"/>
           <a:p xmlns:a="http://schemas.openxmlformats.org/drawingml/2006/main">
             <a:pPr algn="ctr">
+              <a:buNone/>
               <a:defRPr sz="1650" b="1">
                 <a:solidFill>
                   <a:srgbClr val="C53030"/>
@@ -3265,6 +3276,7 @@
           <a:lstStyle xmlns:a="http://schemas.openxmlformats.org/drawingml/2006/main"/>
           <a:p xmlns:a="http://schemas.openxmlformats.org/drawingml/2006/main">
             <a:pPr algn="ctr">
+              <a:buNone/>
               <a:defRPr sz="2025" b="0">
                 <a:solidFill>
                   <a:srgbClr val="000000"/>
@@ -3283,11 +3295,12 @@
                 <a:ea typeface="Helvetica Neue"/>
                 <a:cs typeface="Helvetica Neue"/>
               </a:rPr>
-              <a:t>+59% strategy</a:t>
+              <a:t>+25% strategy</a:t>
             </a:r>
           </a:p>
           <a:p xmlns:a="http://schemas.openxmlformats.org/drawingml/2006/main">
             <a:pPr algn="ctr">
+              <a:buNone/>
               <a:defRPr sz="2025" b="0">
                 <a:solidFill>
                   <a:srgbClr val="000000"/>
@@ -3346,6 +3359,7 @@
           <a:lstStyle xmlns:a="http://schemas.openxmlformats.org/drawingml/2006/main"/>
           <a:p xmlns:a="http://schemas.openxmlformats.org/drawingml/2006/main">
             <a:pPr algn="ctr">
+              <a:buNone/>
               <a:defRPr sz="1350" b="0">
                 <a:solidFill>
                   <a:srgbClr val="667085"/>
@@ -3426,6 +3440,7 @@
           <a:lstStyle xmlns:a="http://schemas.openxmlformats.org/drawingml/2006/main"/>
           <a:p xmlns:a="http://schemas.openxmlformats.org/drawingml/2006/main">
             <a:pPr algn="l">
+              <a:buNone/>
               <a:defRPr sz="2100" b="0">
                 <a:solidFill>
                   <a:srgbClr val="667085"/>
@@ -3484,6 +3499,7 @@
           <a:lstStyle xmlns:a="http://schemas.openxmlformats.org/drawingml/2006/main"/>
           <a:p xmlns:a="http://schemas.openxmlformats.org/drawingml/2006/main">
             <a:pPr algn="l">
+              <a:buNone/>
               <a:defRPr sz="5175" b="0">
                 <a:solidFill>
                   <a:srgbClr val="000000"/>
@@ -3507,6 +3523,7 @@
           </a:p>
           <a:p xmlns:a="http://schemas.openxmlformats.org/drawingml/2006/main">
             <a:pPr algn="l">
+              <a:buNone/>
               <a:defRPr sz="5175" b="0">
                 <a:solidFill>
                   <a:srgbClr val="000000"/>
@@ -3530,6 +3547,7 @@
           </a:p>
           <a:p xmlns:a="http://schemas.openxmlformats.org/drawingml/2006/main">
             <a:pPr algn="l">
+              <a:buNone/>
               <a:defRPr sz="5175" b="0">
                 <a:solidFill>
                   <a:srgbClr val="000000"/>
@@ -3588,6 +3606,7 @@
           <a:lstStyle xmlns:a="http://schemas.openxmlformats.org/drawingml/2006/main"/>
           <a:p xmlns:a="http://schemas.openxmlformats.org/drawingml/2006/main">
             <a:pPr algn="l">
+              <a:buNone/>
               <a:defRPr sz="1875" b="0">
                 <a:solidFill>
                   <a:srgbClr val="000000"/>
@@ -3606,7 +3625,7 @@
                 <a:ea typeface="Helvetica Neue"/>
                 <a:cs typeface="Helvetica Neue"/>
               </a:rPr>
-              <a:t>Six mechanically selected tapes separate absolute return, relative return, and drawdown protection.</a:t>
+              <a:t>Six frozen roles map to four unique assets—duplicates remain visible, not replaced.</a:t>
             </a:r>
           </a:p>
         </p:txBody>
@@ -3646,6 +3665,7 @@
           <a:lstStyle xmlns:a="http://schemas.openxmlformats.org/drawingml/2006/main"/>
           <a:p xmlns:a="http://schemas.openxmlformats.org/drawingml/2006/main">
             <a:pPr algn="r">
+              <a:buNone/>
               <a:defRPr sz="998" b="0">
                 <a:solidFill>
                   <a:srgbClr val="000000"/>
@@ -3726,6 +3746,7 @@
           <a:lstStyle xmlns:a="http://schemas.openxmlformats.org/drawingml/2006/main"/>
           <a:p xmlns:a="http://schemas.openxmlformats.org/drawingml/2006/main">
             <a:pPr algn="l">
+              <a:buNone/>
               <a:defRPr sz="2903" b="0">
                 <a:solidFill>
                   <a:srgbClr val="000000"/>
@@ -3744,7 +3765,7 @@
                 <a:ea typeface="Helvetica Neue"/>
                 <a:cs typeface="Helvetica Neue"/>
               </a:rPr>
-              <a:t>The median asset paid 19 points of return for modest protection</a:t>
+              <a:t>The median asset lost 13% while ownership gained 8%</a:t>
             </a:r>
           </a:p>
         </p:txBody>
@@ -3784,6 +3805,7 @@
           <a:lstStyle xmlns:a="http://schemas.openxmlformats.org/drawingml/2006/main"/>
           <a:p xmlns:a="http://schemas.openxmlformats.org/drawingml/2006/main">
             <a:pPr algn="r">
+              <a:buNone/>
               <a:defRPr sz="998" b="0">
                 <a:solidFill>
                   <a:srgbClr val="000000"/>
@@ -3809,18 +3831,18 @@
       </p:sp>
       <p:pic>
         <p:nvPicPr>
-          <p:cNvPr id="6" name=""/>
+          <p:cNvPr id="8" name=""/>
           <p:cNvPicPr>
             <a:picLocks xmlns:a="http://schemas.openxmlformats.org/drawingml/2006/main" noChangeAspect="1"/>
           </p:cNvPicPr>
           <p:nvPr/>
         </p:nvPicPr>
         <p:blipFill>
-          <a:blip xmlns:r="http://schemas.openxmlformats.org/officeDocument/2006/relationships" xmlns:a="http://schemas.openxmlformats.org/drawingml/2006/main" r:embed="Ra77270c8600b4973"/>
+          <a:blip xmlns:r="http://schemas.openxmlformats.org/officeDocument/2006/relationships" xmlns:a="http://schemas.openxmlformats.org/drawingml/2006/main" r:embed="Rfbaccf6fd71345e5"/>
           <a:stretch xmlns:a="http://schemas.openxmlformats.org/drawingml/2006/main"/>
         </p:blipFill>
         <p:spPr>
-          <a:xfrm xmlns:a="http://schemas.openxmlformats.org/drawingml/2006/main">
+          <a:xfrm xmlns:a="http://schemas.openxmlformats.org/drawingml/2006/main" flipH="0" flipV="0">
             <a:off x="1848716" y="1000125"/>
             <a:ext cx="8494568" cy="5191125"/>
           </a:xfrm>
@@ -3886,6 +3908,7 @@
           <a:lstStyle xmlns:a="http://schemas.openxmlformats.org/drawingml/2006/main"/>
           <a:p xmlns:a="http://schemas.openxmlformats.org/drawingml/2006/main">
             <a:pPr algn="l">
+              <a:buNone/>
               <a:defRPr sz="2903" b="0">
                 <a:solidFill>
                   <a:srgbClr val="000000"/>
@@ -3944,6 +3967,7 @@
           <a:lstStyle xmlns:a="http://schemas.openxmlformats.org/drawingml/2006/main"/>
           <a:p xmlns:a="http://schemas.openxmlformats.org/drawingml/2006/main">
             <a:pPr algn="r">
+              <a:buNone/>
               <a:defRPr sz="998" b="0">
                 <a:solidFill>
                   <a:srgbClr val="000000"/>
@@ -3969,18 +3993,18 @@
       </p:sp>
       <p:pic>
         <p:nvPicPr>
-          <p:cNvPr id="6" name=""/>
+          <p:cNvPr id="8" name=""/>
           <p:cNvPicPr>
             <a:picLocks xmlns:a="http://schemas.openxmlformats.org/drawingml/2006/main" noChangeAspect="1"/>
           </p:cNvPicPr>
           <p:nvPr/>
         </p:nvPicPr>
         <p:blipFill>
-          <a:blip xmlns:r="http://schemas.openxmlformats.org/officeDocument/2006/relationships" xmlns:a="http://schemas.openxmlformats.org/drawingml/2006/main" r:embed="R5eeee2a0501e485f"/>
+          <a:blip xmlns:r="http://schemas.openxmlformats.org/officeDocument/2006/relationships" xmlns:a="http://schemas.openxmlformats.org/drawingml/2006/main" r:embed="Rc2dbf4616048473b"/>
           <a:stretch xmlns:a="http://schemas.openxmlformats.org/drawingml/2006/main"/>
         </p:blipFill>
         <p:spPr>
-          <a:xfrm xmlns:a="http://schemas.openxmlformats.org/drawingml/2006/main">
+          <a:xfrm xmlns:a="http://schemas.openxmlformats.org/drawingml/2006/main" flipH="0" flipV="0">
             <a:off x="1848716" y="1000125"/>
             <a:ext cx="8494568" cy="5191125"/>
           </a:xfrm>
@@ -4046,6 +4070,7 @@
           <a:lstStyle xmlns:a="http://schemas.openxmlformats.org/drawingml/2006/main"/>
           <a:p xmlns:a="http://schemas.openxmlformats.org/drawingml/2006/main">
             <a:pPr algn="l">
+              <a:buNone/>
               <a:defRPr sz="2903" b="0">
                 <a:solidFill>
                   <a:srgbClr val="000000"/>
@@ -4064,7 +4089,7 @@
                 <a:ea typeface="Helvetica Neue"/>
                 <a:cs typeface="Helvetica Neue"/>
               </a:rPr>
-              <a:t>A huge absolute gain can still be the worst relative result</a:t>
+              <a:t>A profitable path can still miss almost the entire trend</a:t>
             </a:r>
           </a:p>
         </p:txBody>
@@ -4104,6 +4129,7 @@
           <a:lstStyle xmlns:a="http://schemas.openxmlformats.org/drawingml/2006/main"/>
           <a:p xmlns:a="http://schemas.openxmlformats.org/drawingml/2006/main">
             <a:pPr algn="r">
+              <a:buNone/>
               <a:defRPr sz="998" b="0">
                 <a:solidFill>
                   <a:srgbClr val="000000"/>
@@ -4129,18 +4155,18 @@
       </p:sp>
       <p:pic>
         <p:nvPicPr>
-          <p:cNvPr id="6" name=""/>
+          <p:cNvPr id="8" name=""/>
           <p:cNvPicPr>
             <a:picLocks xmlns:a="http://schemas.openxmlformats.org/drawingml/2006/main" noChangeAspect="1"/>
           </p:cNvPicPr>
           <p:nvPr/>
         </p:nvPicPr>
         <p:blipFill>
-          <a:blip xmlns:r="http://schemas.openxmlformats.org/officeDocument/2006/relationships" xmlns:a="http://schemas.openxmlformats.org/drawingml/2006/main" r:embed="R47b27189ee0348e2"/>
+          <a:blip xmlns:r="http://schemas.openxmlformats.org/officeDocument/2006/relationships" xmlns:a="http://schemas.openxmlformats.org/drawingml/2006/main" r:embed="Rda70fcb171654325"/>
           <a:stretch xmlns:a="http://schemas.openxmlformats.org/drawingml/2006/main"/>
         </p:blipFill>
         <p:spPr>
-          <a:xfrm xmlns:a="http://schemas.openxmlformats.org/drawingml/2006/main">
+          <a:xfrm xmlns:a="http://schemas.openxmlformats.org/drawingml/2006/main" flipH="0" flipV="0">
             <a:off x="1848716" y="1000125"/>
             <a:ext cx="8494568" cy="5191125"/>
           </a:xfrm>
@@ -4206,6 +4232,7 @@
           <a:lstStyle xmlns:a="http://schemas.openxmlformats.org/drawingml/2006/main"/>
           <a:p xmlns:a="http://schemas.openxmlformats.org/drawingml/2006/main">
             <a:pPr algn="l">
+              <a:buNone/>
               <a:defRPr sz="2903" b="0">
                 <a:solidFill>
                   <a:srgbClr val="000000"/>
@@ -4224,7 +4251,7 @@
                 <a:ea typeface="Helvetica Neue"/>
                 <a:cs typeface="Helvetica Neue"/>
               </a:rPr>
-              <a:t>META shows the rare case where return and drawdown both improved</a:t>
+              <a:t>The strongest drawdown rescue is the same losing CGC path</a:t>
             </a:r>
           </a:p>
         </p:txBody>
@@ -4264,6 +4291,7 @@
           <a:lstStyle xmlns:a="http://schemas.openxmlformats.org/drawingml/2006/main"/>
           <a:p xmlns:a="http://schemas.openxmlformats.org/drawingml/2006/main">
             <a:pPr algn="r">
+              <a:buNone/>
               <a:defRPr sz="998" b="0">
                 <a:solidFill>
                   <a:srgbClr val="000000"/>
@@ -4289,18 +4317,18 @@
       </p:sp>
       <p:pic>
         <p:nvPicPr>
-          <p:cNvPr id="6" name=""/>
+          <p:cNvPr id="8" name=""/>
           <p:cNvPicPr>
             <a:picLocks xmlns:a="http://schemas.openxmlformats.org/drawingml/2006/main" noChangeAspect="1"/>
           </p:cNvPicPr>
           <p:nvPr/>
         </p:nvPicPr>
         <p:blipFill>
-          <a:blip xmlns:r="http://schemas.openxmlformats.org/officeDocument/2006/relationships" xmlns:a="http://schemas.openxmlformats.org/drawingml/2006/main" r:embed="Rf42becb3bd7049af"/>
+          <a:blip xmlns:r="http://schemas.openxmlformats.org/officeDocument/2006/relationships" xmlns:a="http://schemas.openxmlformats.org/drawingml/2006/main" r:embed="Rcb09e623324d45cc"/>
           <a:stretch xmlns:a="http://schemas.openxmlformats.org/drawingml/2006/main"/>
         </p:blipFill>
         <p:spPr>
-          <a:xfrm xmlns:a="http://schemas.openxmlformats.org/drawingml/2006/main">
+          <a:xfrm xmlns:a="http://schemas.openxmlformats.org/drawingml/2006/main" flipH="0" flipV="0">
             <a:off x="1848716" y="1000125"/>
             <a:ext cx="8494568" cy="5191125"/>
           </a:xfrm>
@@ -4366,6 +4394,7 @@
           <a:lstStyle xmlns:a="http://schemas.openxmlformats.org/drawingml/2006/main"/>
           <a:p xmlns:a="http://schemas.openxmlformats.org/drawingml/2006/main">
             <a:pPr algn="l">
+              <a:buNone/>
               <a:defRPr sz="2903" b="0">
                 <a:solidFill>
                   <a:srgbClr val="000000"/>
@@ -4424,6 +4453,7 @@
           <a:lstStyle xmlns:a="http://schemas.openxmlformats.org/drawingml/2006/main"/>
           <a:p xmlns:a="http://schemas.openxmlformats.org/drawingml/2006/main">
             <a:pPr algn="r">
+              <a:buNone/>
               <a:defRPr sz="998" b="0">
                 <a:solidFill>
                   <a:srgbClr val="000000"/>
@@ -4449,18 +4479,18 @@
       </p:sp>
       <p:pic>
         <p:nvPicPr>
-          <p:cNvPr id="6" name=""/>
+          <p:cNvPr id="8" name=""/>
           <p:cNvPicPr>
             <a:picLocks xmlns:a="http://schemas.openxmlformats.org/drawingml/2006/main" noChangeAspect="1"/>
           </p:cNvPicPr>
           <p:nvPr/>
         </p:nvPicPr>
         <p:blipFill>
-          <a:blip xmlns:r="http://schemas.openxmlformats.org/officeDocument/2006/relationships" xmlns:a="http://schemas.openxmlformats.org/drawingml/2006/main" r:embed="R7dcdd44608ad4152"/>
+          <a:blip xmlns:r="http://schemas.openxmlformats.org/officeDocument/2006/relationships" xmlns:a="http://schemas.openxmlformats.org/drawingml/2006/main" r:embed="Rf9df4d99b941478e"/>
           <a:stretch xmlns:a="http://schemas.openxmlformats.org/drawingml/2006/main"/>
         </p:blipFill>
         <p:spPr>
-          <a:xfrm xmlns:a="http://schemas.openxmlformats.org/drawingml/2006/main">
+          <a:xfrm xmlns:a="http://schemas.openxmlformats.org/drawingml/2006/main" flipH="0" flipV="0">
             <a:off x="1848716" y="1000125"/>
             <a:ext cx="8494568" cy="5191125"/>
           </a:xfrm>
@@ -4526,6 +4556,7 @@
           <a:lstStyle xmlns:a="http://schemas.openxmlformats.org/drawingml/2006/main"/>
           <a:p xmlns:a="http://schemas.openxmlformats.org/drawingml/2006/main">
             <a:pPr algn="l">
+              <a:buNone/>
               <a:defRPr sz="2903" b="0">
                 <a:solidFill>
                   <a:srgbClr val="000000"/>
@@ -4544,7 +4575,7 @@
                 <a:ea typeface="Helvetica Neue"/>
                 <a:cs typeface="Helvetica Neue"/>
               </a:rPr>
-              <a:t>A persistent trend can make the simple rule look clean</a:t>
+              <a:t>The longest median hold is also the worst relative miss</a:t>
             </a:r>
           </a:p>
         </p:txBody>
@@ -4584,6 +4615,7 @@
           <a:lstStyle xmlns:a="http://schemas.openxmlformats.org/drawingml/2006/main"/>
           <a:p xmlns:a="http://schemas.openxmlformats.org/drawingml/2006/main">
             <a:pPr algn="r">
+              <a:buNone/>
               <a:defRPr sz="998" b="0">
                 <a:solidFill>
                   <a:srgbClr val="000000"/>
@@ -4609,18 +4641,18 @@
       </p:sp>
       <p:pic>
         <p:nvPicPr>
-          <p:cNvPr id="6" name=""/>
+          <p:cNvPr id="8" name=""/>
           <p:cNvPicPr>
             <a:picLocks xmlns:a="http://schemas.openxmlformats.org/drawingml/2006/main" noChangeAspect="1"/>
           </p:cNvPicPr>
           <p:nvPr/>
         </p:nvPicPr>
         <p:blipFill>
-          <a:blip xmlns:r="http://schemas.openxmlformats.org/officeDocument/2006/relationships" xmlns:a="http://schemas.openxmlformats.org/drawingml/2006/main" r:embed="R4f87e0b245b24ce8"/>
+          <a:blip xmlns:r="http://schemas.openxmlformats.org/officeDocument/2006/relationships" xmlns:a="http://schemas.openxmlformats.org/drawingml/2006/main" r:embed="R43085d3fb6cc4083"/>
           <a:stretch xmlns:a="http://schemas.openxmlformats.org/drawingml/2006/main"/>
         </p:blipFill>
         <p:spPr>
-          <a:xfrm xmlns:a="http://schemas.openxmlformats.org/drawingml/2006/main">
+          <a:xfrm xmlns:a="http://schemas.openxmlformats.org/drawingml/2006/main" flipH="0" flipV="0">
             <a:off x="1848716" y="1000125"/>
             <a:ext cx="8494568" cy="5191125"/>
           </a:xfrm>
@@ -4681,11 +4713,12 @@
         </p:spPr>
         <p:txBody>
           <a:bodyPr xmlns:a="http://schemas.openxmlformats.org/drawingml/2006/main" wrap="square" lIns="0" tIns="0" rIns="0" bIns="0" anchor="t">
-            <a:normAutofit fontScale="94993"/>
+            <a:normAutofit fontScale="100000"/>
           </a:bodyPr>
           <a:lstStyle xmlns:a="http://schemas.openxmlformats.org/drawingml/2006/main"/>
           <a:p xmlns:a="http://schemas.openxmlformats.org/drawingml/2006/main">
             <a:pPr algn="l">
+              <a:buNone/>
               <a:defRPr sz="2903" b="0">
                 <a:solidFill>
                   <a:srgbClr val="000000"/>
@@ -4704,7 +4737,7 @@
                 <a:ea typeface="Helvetica Neue"/>
                 <a:cs typeface="Helvetica Neue"/>
               </a:rPr>
-              <a:t>The 200-session cross is a defensible risk filter—not a demonstrated timing edge</a:t>
+              <a:t>Fresh SMA200 crosses reduced drawdown—but did not show a timing edge</a:t>
             </a:r>
           </a:p>
         </p:txBody>
@@ -4744,6 +4777,7 @@
           <a:lstStyle xmlns:a="http://schemas.openxmlformats.org/drawingml/2006/main"/>
           <a:p xmlns:a="http://schemas.openxmlformats.org/drawingml/2006/main">
             <a:pPr algn="r">
+              <a:buNone/>
               <a:defRPr sz="998" b="0">
                 <a:solidFill>
                   <a:srgbClr val="000000"/>
@@ -4802,6 +4836,7 @@
           <a:lstStyle xmlns:a="http://schemas.openxmlformats.org/drawingml/2006/main"/>
           <a:p xmlns:a="http://schemas.openxmlformats.org/drawingml/2006/main">
             <a:pPr algn="l">
+              <a:buNone/>
               <a:defRPr sz="1650" b="1">
                 <a:solidFill>
                   <a:srgbClr val="2F855A"/>
@@ -4860,6 +4895,7 @@
           <a:lstStyle xmlns:a="http://schemas.openxmlformats.org/drawingml/2006/main"/>
           <a:p xmlns:a="http://schemas.openxmlformats.org/drawingml/2006/main">
             <a:pPr algn="l">
+              <a:buNone/>
               <a:defRPr sz="2100" b="0">
                 <a:solidFill>
                   <a:srgbClr val="000000"/>
@@ -4878,11 +4914,12 @@
                 <a:ea typeface="Helvetica Neue"/>
                 <a:cs typeface="Helvetica Neue"/>
               </a:rPr>
-              <a:t>Drawdown improved in 79/119 assets</a:t>
+              <a:t>Drawdown improved in 88/119 assets</a:t>
             </a:r>
           </a:p>
           <a:p xmlns:a="http://schemas.openxmlformats.org/drawingml/2006/main">
             <a:pPr algn="l">
+              <a:buNone/>
               <a:defRPr sz="2100" b="0">
                 <a:solidFill>
                   <a:srgbClr val="000000"/>
@@ -4901,11 +4938,12 @@
                 <a:ea typeface="Helvetica Neue"/>
                 <a:cs typeface="Helvetica Neue"/>
               </a:rPr>
-              <a:t>Long cash intervals softened some collapses</a:t>
+              <a:t>Cross-only paths spent 43% invested</a:t>
             </a:r>
           </a:p>
           <a:p xmlns:a="http://schemas.openxmlformats.org/drawingml/2006/main">
             <a:pPr algn="l">
+              <a:buNone/>
               <a:defRPr sz="2100" b="0">
                 <a:solidFill>
                   <a:srgbClr val="000000"/>
@@ -4924,7 +4962,7 @@
                 <a:ea typeface="Helvetica Neue"/>
                 <a:cs typeface="Helvetica Neue"/>
               </a:rPr>
-              <a:t>A few persistent trends paid for many losses</a:t>
+              <a:t>Cash intervals softened some collapses</a:t>
             </a:r>
           </a:p>
         </p:txBody>
@@ -4997,6 +5035,7 @@
           <a:lstStyle xmlns:a="http://schemas.openxmlformats.org/drawingml/2006/main"/>
           <a:p xmlns:a="http://schemas.openxmlformats.org/drawingml/2006/main">
             <a:pPr algn="l">
+              <a:buNone/>
               <a:defRPr sz="1650" b="1">
                 <a:solidFill>
                   <a:srgbClr val="C53030"/>
@@ -5055,6 +5094,7 @@
           <a:lstStyle xmlns:a="http://schemas.openxmlformats.org/drawingml/2006/main"/>
           <a:p xmlns:a="http://schemas.openxmlformats.org/drawingml/2006/main">
             <a:pPr algn="l">
+              <a:buNone/>
               <a:defRPr sz="2100" b="0">
                 <a:solidFill>
                   <a:srgbClr val="000000"/>
@@ -5078,6 +5118,7 @@
           </a:p>
           <a:p xmlns:a="http://schemas.openxmlformats.org/drawingml/2006/main">
             <a:pPr algn="l">
+              <a:buNone/>
               <a:defRPr sz="2100" b="0">
                 <a:solidFill>
                   <a:srgbClr val="000000"/>
@@ -5101,6 +5142,7 @@
           </a:p>
           <a:p xmlns:a="http://schemas.openxmlformats.org/drawingml/2006/main">
             <a:pPr algn="l">
+              <a:buNone/>
               <a:defRPr sz="2100" b="0">
                 <a:solidFill>
                   <a:srgbClr val="000000"/>
@@ -5124,6 +5166,7 @@
           </a:p>
           <a:p xmlns:a="http://schemas.openxmlformats.org/drawingml/2006/main">
             <a:pPr algn="l">
+              <a:buNone/>
               <a:defRPr sz="2100" b="0">
                 <a:solidFill>
                   <a:srgbClr val="000000"/>
@@ -5182,6 +5225,7 @@
           <a:lstStyle xmlns:a="http://schemas.openxmlformats.org/drawingml/2006/main"/>
           <a:p xmlns:a="http://schemas.openxmlformats.org/drawingml/2006/main">
             <a:pPr algn="ctr">
+              <a:buNone/>
               <a:defRPr sz="1725" b="0">
                 <a:solidFill>
                   <a:srgbClr val="667085"/>
@@ -5262,6 +5306,7 @@
           <a:lstStyle xmlns:a="http://schemas.openxmlformats.org/drawingml/2006/main"/>
           <a:p xmlns:a="http://schemas.openxmlformats.org/drawingml/2006/main">
             <a:pPr algn="l">
+              <a:buNone/>
               <a:defRPr sz="2903" b="0">
                 <a:solidFill>
                   <a:srgbClr val="000000"/>
@@ -5280,7 +5325,7 @@
                 <a:ea typeface="Helvetica Neue"/>
                 <a:cs typeface="Helvetica Neue"/>
               </a:rPr>
-              <a:t>One completed-close state determines the next-open position</a:t>
+              <a:t>A fresh completed-close cross determines the next-open trade</a:t>
             </a:r>
           </a:p>
         </p:txBody>
@@ -5320,6 +5365,7 @@
           <a:lstStyle xmlns:a="http://schemas.openxmlformats.org/drawingml/2006/main"/>
           <a:p xmlns:a="http://schemas.openxmlformats.org/drawingml/2006/main">
             <a:pPr algn="r">
+              <a:buNone/>
               <a:defRPr sz="998" b="0">
                 <a:solidFill>
                   <a:srgbClr val="000000"/>
@@ -5378,6 +5424,7 @@
           <a:lstStyle xmlns:a="http://schemas.openxmlformats.org/drawingml/2006/main"/>
           <a:p xmlns:a="http://schemas.openxmlformats.org/drawingml/2006/main">
             <a:pPr algn="ctr">
+              <a:buNone/>
               <a:defRPr sz="2550" b="1">
                 <a:solidFill>
                   <a:srgbClr val="000000"/>
@@ -5469,6 +5516,7 @@
           <a:lstStyle xmlns:a="http://schemas.openxmlformats.org/drawingml/2006/main"/>
           <a:p xmlns:a="http://schemas.openxmlformats.org/drawingml/2006/main">
             <a:pPr algn="ctr">
+              <a:buNone/>
               <a:defRPr sz="1875" b="1">
                 <a:solidFill>
                   <a:srgbClr val="2F855A"/>
@@ -5487,7 +5535,7 @@
                 <a:ea typeface="Helvetica Neue"/>
                 <a:cs typeface="Helvetica Neue"/>
               </a:rPr>
-              <a:t>CLOSE &gt; SMA200</a:t>
+              <a:t>CROSS ABOVE</a:t>
             </a:r>
           </a:p>
         </p:txBody>
@@ -5527,6 +5575,7 @@
           <a:lstStyle xmlns:a="http://schemas.openxmlformats.org/drawingml/2006/main"/>
           <a:p xmlns:a="http://schemas.openxmlformats.org/drawingml/2006/main">
             <a:pPr algn="ctr">
+              <a:buNone/>
               <a:defRPr sz="2400" b="1">
                 <a:solidFill>
                   <a:srgbClr val="000000"/>
@@ -5545,11 +5594,12 @@
                 <a:ea typeface="Helvetica Neue"/>
                 <a:cs typeface="Helvetica Neue"/>
               </a:rPr>
-              <a:t>Buy or remain long</a:t>
+              <a:t>Buy at the next open</a:t>
             </a:r>
           </a:p>
           <a:p xmlns:a="http://schemas.openxmlformats.org/drawingml/2006/main">
             <a:pPr algn="ctr">
+              <a:buNone/>
               <a:defRPr sz="2400" b="1">
                 <a:solidFill>
                   <a:srgbClr val="000000"/>
@@ -5568,7 +5618,7 @@
                 <a:ea typeface="Helvetica Neue"/>
                 <a:cs typeface="Helvetica Neue"/>
               </a:rPr>
-              <a:t>at the next open</a:t>
+              <a:t>then remain long</a:t>
             </a:r>
           </a:p>
         </p:txBody>
@@ -5641,6 +5691,7 @@
           <a:lstStyle xmlns:a="http://schemas.openxmlformats.org/drawingml/2006/main"/>
           <a:p xmlns:a="http://schemas.openxmlformats.org/drawingml/2006/main">
             <a:pPr algn="ctr">
+              <a:buNone/>
               <a:defRPr sz="1875" b="1">
                 <a:solidFill>
                   <a:srgbClr val="000000"/>
@@ -5659,7 +5710,7 @@
                 <a:ea typeface="Helvetica Neue"/>
                 <a:cs typeface="Helvetica Neue"/>
               </a:rPr>
-              <a:t>CLOSE &lt;= SMA200</a:t>
+              <a:t>CROSS BELOW</a:t>
             </a:r>
           </a:p>
         </p:txBody>
@@ -5699,6 +5750,7 @@
           <a:lstStyle xmlns:a="http://schemas.openxmlformats.org/drawingml/2006/main"/>
           <a:p xmlns:a="http://schemas.openxmlformats.org/drawingml/2006/main">
             <a:pPr algn="ctr">
+              <a:buNone/>
               <a:defRPr sz="2400" b="1">
                 <a:solidFill>
                   <a:srgbClr val="000000"/>
@@ -5717,11 +5769,12 @@
                 <a:ea typeface="Helvetica Neue"/>
                 <a:cs typeface="Helvetica Neue"/>
               </a:rPr>
-              <a:t>Sell or remain cash</a:t>
+              <a:t>Sell at the next open</a:t>
             </a:r>
           </a:p>
           <a:p xmlns:a="http://schemas.openxmlformats.org/drawingml/2006/main">
             <a:pPr algn="ctr">
+              <a:buNone/>
               <a:defRPr sz="2400" b="1">
                 <a:solidFill>
                   <a:srgbClr val="000000"/>
@@ -5740,7 +5793,7 @@
                 <a:ea typeface="Helvetica Neue"/>
                 <a:cs typeface="Helvetica Neue"/>
               </a:rPr>
-              <a:t>at the next open</a:t>
+              <a:t>then remain cash</a:t>
             </a:r>
           </a:p>
         </p:txBody>
@@ -5780,6 +5833,7 @@
           <a:lstStyle xmlns:a="http://schemas.openxmlformats.org/drawingml/2006/main"/>
           <a:p xmlns:a="http://schemas.openxmlformats.org/drawingml/2006/main">
             <a:pPr algn="ctr">
+              <a:buNone/>
               <a:defRPr sz="1575" b="0">
                 <a:solidFill>
                   <a:srgbClr val="667085"/>
@@ -5798,7 +5852,7 @@
                 <a:ea typeface="Helvetica Neue"/>
                 <a:cs typeface="Helvetica Neue"/>
               </a:rPr>
-              <a:t>Adjusted daily bars | 5 bp/side primary | 10 bp/side stress | full capital within each asset</a:t>
+              <a:t>Every path starts in cash | adjusted daily | 5 bp/side primary | 10 bp/side stress</a:t>
             </a:r>
           </a:p>
         </p:txBody>
@@ -5860,6 +5914,7 @@
           <a:lstStyle xmlns:a="http://schemas.openxmlformats.org/drawingml/2006/main"/>
           <a:p xmlns:a="http://schemas.openxmlformats.org/drawingml/2006/main">
             <a:pPr algn="l">
+              <a:buNone/>
               <a:defRPr sz="2903" b="0">
                 <a:solidFill>
                   <a:srgbClr val="000000"/>
@@ -5918,6 +5973,7 @@
           <a:lstStyle xmlns:a="http://schemas.openxmlformats.org/drawingml/2006/main"/>
           <a:p xmlns:a="http://schemas.openxmlformats.org/drawingml/2006/main">
             <a:pPr algn="r">
+              <a:buNone/>
               <a:defRPr sz="998" b="0">
                 <a:solidFill>
                   <a:srgbClr val="000000"/>
@@ -5976,6 +6032,7 @@
           <a:lstStyle xmlns:a="http://schemas.openxmlformats.org/drawingml/2006/main"/>
           <a:p xmlns:a="http://schemas.openxmlformats.org/drawingml/2006/main">
             <a:pPr algn="l">
+              <a:buNone/>
               <a:defRPr sz="1800" b="1">
                 <a:solidFill>
                   <a:srgbClr val="2F855A"/>
@@ -6034,6 +6091,7 @@
           <a:lstStyle xmlns:a="http://schemas.openxmlformats.org/drawingml/2006/main"/>
           <a:p xmlns:a="http://schemas.openxmlformats.org/drawingml/2006/main">
             <a:pPr algn="l">
+              <a:buNone/>
               <a:defRPr sz="2250" b="0">
                 <a:solidFill>
                   <a:srgbClr val="000000"/>
@@ -6057,6 +6115,7 @@
           </a:p>
           <a:p xmlns:a="http://schemas.openxmlformats.org/drawingml/2006/main">
             <a:pPr algn="l">
+              <a:buNone/>
               <a:defRPr sz="2250" b="0">
                 <a:solidFill>
                   <a:srgbClr val="000000"/>
@@ -6080,6 +6139,7 @@
           </a:p>
           <a:p xmlns:a="http://schemas.openxmlformats.org/drawingml/2006/main">
             <a:pPr algn="l">
+              <a:buNone/>
               <a:defRPr sz="2250" b="0">
                 <a:solidFill>
                   <a:srgbClr val="000000"/>
@@ -6171,6 +6231,7 @@
           <a:lstStyle xmlns:a="http://schemas.openxmlformats.org/drawingml/2006/main"/>
           <a:p xmlns:a="http://schemas.openxmlformats.org/drawingml/2006/main">
             <a:pPr algn="l">
+              <a:buNone/>
               <a:defRPr sz="1800" b="1">
                 <a:solidFill>
                   <a:srgbClr val="C53030"/>
@@ -6229,6 +6290,7 @@
           <a:lstStyle xmlns:a="http://schemas.openxmlformats.org/drawingml/2006/main"/>
           <a:p xmlns:a="http://schemas.openxmlformats.org/drawingml/2006/main">
             <a:pPr algn="l">
+              <a:buNone/>
               <a:defRPr sz="2250" b="0">
                 <a:solidFill>
                   <a:srgbClr val="000000"/>
@@ -6252,6 +6314,7 @@
           </a:p>
           <a:p xmlns:a="http://schemas.openxmlformats.org/drawingml/2006/main">
             <a:pPr algn="l">
+              <a:buNone/>
               <a:defRPr sz="2250" b="0">
                 <a:solidFill>
                   <a:srgbClr val="000000"/>
@@ -6275,6 +6338,7 @@
           </a:p>
           <a:p xmlns:a="http://schemas.openxmlformats.org/drawingml/2006/main">
             <a:pPr algn="l">
+              <a:buNone/>
               <a:defRPr sz="2250" b="0">
                 <a:solidFill>
                   <a:srgbClr val="000000"/>
@@ -6298,6 +6362,7 @@
           </a:p>
           <a:p xmlns:a="http://schemas.openxmlformats.org/drawingml/2006/main">
             <a:pPr algn="l">
+              <a:buNone/>
               <a:defRPr sz="2250" b="0">
                 <a:solidFill>
                   <a:srgbClr val="000000"/>
@@ -6356,6 +6421,7 @@
           <a:lstStyle xmlns:a="http://schemas.openxmlformats.org/drawingml/2006/main"/>
           <a:p xmlns:a="http://schemas.openxmlformats.org/drawingml/2006/main">
             <a:pPr algn="ctr">
+              <a:buNone/>
               <a:defRPr sz="1800" b="0">
                 <a:solidFill>
                   <a:srgbClr val="667085"/>
@@ -6374,7 +6440,7 @@
                 <a:ea typeface="Helvetica Neue"/>
                 <a:cs typeface="Helvetica Neue"/>
               </a:rPr>
-              <a:t>The correct estimand is the full return / drawdown / exposure tradeoff after costs.</a:t>
+              <a:t>The estimand is the cross-triggered return / drawdown / exposure tradeoff after costs.</a:t>
             </a:r>
           </a:p>
         </p:txBody>
@@ -6436,6 +6502,7 @@
           <a:lstStyle xmlns:a="http://schemas.openxmlformats.org/drawingml/2006/main"/>
           <a:p xmlns:a="http://schemas.openxmlformats.org/drawingml/2006/main">
             <a:pPr algn="l">
+              <a:buNone/>
               <a:defRPr sz="2903" b="0">
                 <a:solidFill>
                   <a:srgbClr val="000000"/>
@@ -6494,6 +6561,7 @@
           <a:lstStyle xmlns:a="http://schemas.openxmlformats.org/drawingml/2006/main"/>
           <a:p xmlns:a="http://schemas.openxmlformats.org/drawingml/2006/main">
             <a:pPr algn="r">
+              <a:buNone/>
               <a:defRPr sz="998" b="0">
                 <a:solidFill>
                   <a:srgbClr val="000000"/>
@@ -6519,18 +6587,18 @@
       </p:sp>
       <p:pic>
         <p:nvPicPr>
-          <p:cNvPr id="6" name=""/>
+          <p:cNvPr id="8" name=""/>
           <p:cNvPicPr>
             <a:picLocks xmlns:a="http://schemas.openxmlformats.org/drawingml/2006/main" noChangeAspect="1"/>
           </p:cNvPicPr>
           <p:nvPr/>
         </p:nvPicPr>
         <p:blipFill>
-          <a:blip xmlns:r="http://schemas.openxmlformats.org/officeDocument/2006/relationships" xmlns:a="http://schemas.openxmlformats.org/drawingml/2006/main" r:embed="R7778e6f38bf34f2e"/>
+          <a:blip xmlns:r="http://schemas.openxmlformats.org/officeDocument/2006/relationships" xmlns:a="http://schemas.openxmlformats.org/drawingml/2006/main" r:embed="R13c793c27be444a8"/>
           <a:stretch xmlns:a="http://schemas.openxmlformats.org/drawingml/2006/main"/>
         </p:blipFill>
         <p:spPr>
-          <a:xfrm xmlns:a="http://schemas.openxmlformats.org/drawingml/2006/main">
+          <a:xfrm xmlns:a="http://schemas.openxmlformats.org/drawingml/2006/main" flipH="0" flipV="0">
             <a:off x="1423988" y="1000125"/>
             <a:ext cx="9344025" cy="5191125"/>
           </a:xfrm>
@@ -6596,6 +6664,7 @@
           <a:lstStyle xmlns:a="http://schemas.openxmlformats.org/drawingml/2006/main"/>
           <a:p xmlns:a="http://schemas.openxmlformats.org/drawingml/2006/main">
             <a:pPr algn="l">
+              <a:buNone/>
               <a:defRPr sz="2903" b="0">
                 <a:solidFill>
                   <a:srgbClr val="000000"/>
@@ -6614,7 +6683,7 @@
                 <a:ea typeface="Helvetica Neue"/>
                 <a:cs typeface="Helvetica Neue"/>
               </a:rPr>
-              <a:t>The typical path earned less, spent less time exposed, and drew down less</a:t>
+              <a:t>Fresh-cross paths lost money typically and still reduced drawdown</a:t>
             </a:r>
           </a:p>
         </p:txBody>
@@ -6654,6 +6723,7 @@
           <a:lstStyle xmlns:a="http://schemas.openxmlformats.org/drawingml/2006/main"/>
           <a:p xmlns:a="http://schemas.openxmlformats.org/drawingml/2006/main">
             <a:pPr algn="r">
+              <a:buNone/>
               <a:defRPr sz="998" b="0">
                 <a:solidFill>
                   <a:srgbClr val="000000"/>
@@ -6712,6 +6782,7 @@
           <a:lstStyle xmlns:a="http://schemas.openxmlformats.org/drawingml/2006/main"/>
           <a:p xmlns:a="http://schemas.openxmlformats.org/drawingml/2006/main">
             <a:pPr algn="ctr">
+              <a:buNone/>
               <a:defRPr sz="3600" b="1">
                 <a:solidFill>
                   <a:srgbClr val="2F855A"/>
@@ -6730,7 +6801,7 @@
                 <a:ea typeface="Helvetica Neue"/>
                 <a:cs typeface="Helvetica Neue"/>
               </a:rPr>
-              <a:t>+6.24%</a:t>
+              <a:t>-2.73%</a:t>
             </a:r>
           </a:p>
         </p:txBody>
@@ -6770,6 +6841,7 @@
           <a:lstStyle xmlns:a="http://schemas.openxmlformats.org/drawingml/2006/main"/>
           <a:p xmlns:a="http://schemas.openxmlformats.org/drawingml/2006/main">
             <a:pPr algn="ctr">
+              <a:buNone/>
               <a:defRPr sz="1800" b="1">
                 <a:solidFill>
                   <a:srgbClr val="000000"/>
@@ -6828,6 +6900,7 @@
           <a:lstStyle xmlns:a="http://schemas.openxmlformats.org/drawingml/2006/main"/>
           <a:p xmlns:a="http://schemas.openxmlformats.org/drawingml/2006/main">
             <a:pPr algn="ctr">
+              <a:buNone/>
               <a:defRPr sz="1275" b="0">
                 <a:solidFill>
                   <a:srgbClr val="667085"/>
@@ -6886,6 +6959,7 @@
           <a:lstStyle xmlns:a="http://schemas.openxmlformats.org/drawingml/2006/main"/>
           <a:p xmlns:a="http://schemas.openxmlformats.org/drawingml/2006/main">
             <a:pPr algn="ctr">
+              <a:buNone/>
               <a:defRPr sz="3600" b="1">
                 <a:solidFill>
                   <a:srgbClr val="C53030"/>
@@ -6904,7 +6978,7 @@
                 <a:ea typeface="Helvetica Neue"/>
                 <a:cs typeface="Helvetica Neue"/>
               </a:rPr>
-              <a:t>-19.33 pp</a:t>
+              <a:t>-21.76 pp</a:t>
             </a:r>
           </a:p>
         </p:txBody>
@@ -6944,6 +7018,7 @@
           <a:lstStyle xmlns:a="http://schemas.openxmlformats.org/drawingml/2006/main"/>
           <a:p xmlns:a="http://schemas.openxmlformats.org/drawingml/2006/main">
             <a:pPr algn="ctr">
+              <a:buNone/>
               <a:defRPr sz="1800" b="1">
                 <a:solidFill>
                   <a:srgbClr val="000000"/>
@@ -7002,6 +7077,7 @@
           <a:lstStyle xmlns:a="http://schemas.openxmlformats.org/drawingml/2006/main"/>
           <a:p xmlns:a="http://schemas.openxmlformats.org/drawingml/2006/main">
             <a:pPr algn="ctr">
+              <a:buNone/>
               <a:defRPr sz="1275" b="0">
                 <a:solidFill>
                   <a:srgbClr val="667085"/>
@@ -7020,7 +7096,7 @@
                 <a:ea typeface="Helvetica Neue"/>
                 <a:cs typeface="Helvetica Neue"/>
               </a:rPr>
-              <a:t>only 30 of 119 beat ownership</a:t>
+              <a:t>only 26 of 119 beat ownership</a:t>
             </a:r>
           </a:p>
         </p:txBody>
@@ -7060,6 +7136,7 @@
           <a:lstStyle xmlns:a="http://schemas.openxmlformats.org/drawingml/2006/main"/>
           <a:p xmlns:a="http://schemas.openxmlformats.org/drawingml/2006/main">
             <a:pPr algn="ctr">
+              <a:buNone/>
               <a:defRPr sz="3600" b="1">
                 <a:solidFill>
                   <a:srgbClr val="3D8DFF"/>
@@ -7078,7 +7155,7 @@
                 <a:ea typeface="Helvetica Neue"/>
                 <a:cs typeface="Helvetica Neue"/>
               </a:rPr>
-              <a:t>60.82%</a:t>
+              <a:t>43.48%</a:t>
             </a:r>
           </a:p>
         </p:txBody>
@@ -7118,6 +7195,7 @@
           <a:lstStyle xmlns:a="http://schemas.openxmlformats.org/drawingml/2006/main"/>
           <a:p xmlns:a="http://schemas.openxmlformats.org/drawingml/2006/main">
             <a:pPr algn="ctr">
+              <a:buNone/>
               <a:defRPr sz="1800" b="1">
                 <a:solidFill>
                   <a:srgbClr val="000000"/>
@@ -7176,6 +7254,7 @@
           <a:lstStyle xmlns:a="http://schemas.openxmlformats.org/drawingml/2006/main"/>
           <a:p xmlns:a="http://schemas.openxmlformats.org/drawingml/2006/main">
             <a:pPr algn="ctr">
+              <a:buNone/>
               <a:defRPr sz="1275" b="0">
                 <a:solidFill>
                   <a:srgbClr val="667085"/>
@@ -7194,7 +7273,7 @@
                 <a:ea typeface="Helvetica Neue"/>
                 <a:cs typeface="Helvetica Neue"/>
               </a:rPr>
-              <a:t>cash for roughly two sessions in five</a:t>
+              <a:t>cash for more than half of sessions</a:t>
             </a:r>
           </a:p>
         </p:txBody>
@@ -7234,6 +7313,7 @@
           <a:lstStyle xmlns:a="http://schemas.openxmlformats.org/drawingml/2006/main"/>
           <a:p xmlns:a="http://schemas.openxmlformats.org/drawingml/2006/main">
             <a:pPr algn="ctr">
+              <a:buNone/>
               <a:defRPr sz="3600" b="1">
                 <a:solidFill>
                   <a:srgbClr val="3D8DFF"/>
@@ -7252,7 +7332,7 @@
                 <a:ea typeface="Helvetica Neue"/>
                 <a:cs typeface="Helvetica Neue"/>
               </a:rPr>
-              <a:t>+4.31 pp</a:t>
+              <a:t>+5.98 pp</a:t>
             </a:r>
           </a:p>
         </p:txBody>
@@ -7292,6 +7372,7 @@
           <a:lstStyle xmlns:a="http://schemas.openxmlformats.org/drawingml/2006/main"/>
           <a:p xmlns:a="http://schemas.openxmlformats.org/drawingml/2006/main">
             <a:pPr algn="ctr">
+              <a:buNone/>
               <a:defRPr sz="1800" b="1">
                 <a:solidFill>
                   <a:srgbClr val="000000"/>
@@ -7350,6 +7431,7 @@
           <a:lstStyle xmlns:a="http://schemas.openxmlformats.org/drawingml/2006/main"/>
           <a:p xmlns:a="http://schemas.openxmlformats.org/drawingml/2006/main">
             <a:pPr algn="ctr">
+              <a:buNone/>
               <a:defRPr sz="1275" b="0">
                 <a:solidFill>
                   <a:srgbClr val="667085"/>
@@ -7368,7 +7450,7 @@
                 <a:ea typeface="Helvetica Neue"/>
                 <a:cs typeface="Helvetica Neue"/>
               </a:rPr>
-              <a:t>-30.12% versus -36.73% ownership</a:t>
+              <a:t>-28.11% versus -36.73% ownership</a:t>
             </a:r>
           </a:p>
         </p:txBody>
@@ -7408,6 +7490,7 @@
           <a:lstStyle xmlns:a="http://schemas.openxmlformats.org/drawingml/2006/main"/>
           <a:p xmlns:a="http://schemas.openxmlformats.org/drawingml/2006/main">
             <a:pPr algn="ctr">
+              <a:buNone/>
               <a:defRPr sz="1650" b="0">
                 <a:solidFill>
                   <a:srgbClr val="667085"/>
@@ -7426,7 +7509,7 @@
                 <a:ea typeface="Helvetica Neue"/>
                 <a:cs typeface="Helvetica Neue"/>
               </a:rPr>
-              <a:t>70/119 positive paths | 79/119 reduced drawdown | 64/119 remained positive at stress costs</a:t>
+              <a:t>52/119 positive paths | 88/119 reduced drawdown | 50/119 remained positive at stress costs</a:t>
             </a:r>
           </a:p>
         </p:txBody>
@@ -7488,6 +7571,7 @@
           <a:lstStyle xmlns:a="http://schemas.openxmlformats.org/drawingml/2006/main"/>
           <a:p xmlns:a="http://schemas.openxmlformats.org/drawingml/2006/main">
             <a:pPr algn="l">
+              <a:buNone/>
               <a:defRPr sz="2903" b="0">
                 <a:solidFill>
                   <a:srgbClr val="000000"/>
@@ -7546,6 +7630,7 @@
           <a:lstStyle xmlns:a="http://schemas.openxmlformats.org/drawingml/2006/main"/>
           <a:p xmlns:a="http://schemas.openxmlformats.org/drawingml/2006/main">
             <a:pPr algn="r">
+              <a:buNone/>
               <a:defRPr sz="998" b="0">
                 <a:solidFill>
                   <a:srgbClr val="000000"/>
@@ -7571,18 +7656,18 @@
       </p:sp>
       <p:pic>
         <p:nvPicPr>
-          <p:cNvPr id="6" name=""/>
+          <p:cNvPr id="8" name=""/>
           <p:cNvPicPr>
             <a:picLocks xmlns:a="http://schemas.openxmlformats.org/drawingml/2006/main" noChangeAspect="1"/>
           </p:cNvPicPr>
           <p:nvPr/>
         </p:nvPicPr>
         <p:blipFill>
-          <a:blip xmlns:r="http://schemas.openxmlformats.org/officeDocument/2006/relationships" xmlns:a="http://schemas.openxmlformats.org/drawingml/2006/main" r:embed="R405dbce345d1447f"/>
+          <a:blip xmlns:r="http://schemas.openxmlformats.org/officeDocument/2006/relationships" xmlns:a="http://schemas.openxmlformats.org/drawingml/2006/main" r:embed="R5e5f6e5a4956436e"/>
           <a:stretch xmlns:a="http://schemas.openxmlformats.org/drawingml/2006/main"/>
         </p:blipFill>
         <p:spPr>
-          <a:xfrm xmlns:a="http://schemas.openxmlformats.org/drawingml/2006/main">
+          <a:xfrm xmlns:a="http://schemas.openxmlformats.org/drawingml/2006/main" flipH="0" flipV="0">
             <a:off x="1423988" y="1000125"/>
             <a:ext cx="9344025" cy="5191125"/>
           </a:xfrm>
@@ -7648,6 +7733,7 @@
           <a:lstStyle xmlns:a="http://schemas.openxmlformats.org/drawingml/2006/main"/>
           <a:p xmlns:a="http://schemas.openxmlformats.org/drawingml/2006/main">
             <a:pPr algn="l">
+              <a:buNone/>
               <a:defRPr sz="2903" b="0">
                 <a:solidFill>
                   <a:srgbClr val="000000"/>
@@ -7706,6 +7792,7 @@
           <a:lstStyle xmlns:a="http://schemas.openxmlformats.org/drawingml/2006/main"/>
           <a:p xmlns:a="http://schemas.openxmlformats.org/drawingml/2006/main">
             <a:pPr algn="r">
+              <a:buNone/>
               <a:defRPr sz="998" b="0">
                 <a:solidFill>
                   <a:srgbClr val="000000"/>
@@ -7731,18 +7818,18 @@
       </p:sp>
       <p:pic>
         <p:nvPicPr>
-          <p:cNvPr id="6" name=""/>
+          <p:cNvPr id="8" name=""/>
           <p:cNvPicPr>
             <a:picLocks xmlns:a="http://schemas.openxmlformats.org/drawingml/2006/main" noChangeAspect="1"/>
           </p:cNvPicPr>
           <p:nvPr/>
         </p:nvPicPr>
         <p:blipFill>
-          <a:blip xmlns:r="http://schemas.openxmlformats.org/officeDocument/2006/relationships" xmlns:a="http://schemas.openxmlformats.org/drawingml/2006/main" r:embed="Rc6bdfdeb13f342c1"/>
+          <a:blip xmlns:r="http://schemas.openxmlformats.org/officeDocument/2006/relationships" xmlns:a="http://schemas.openxmlformats.org/drawingml/2006/main" r:embed="R5dad24e0ecd2466c"/>
           <a:stretch xmlns:a="http://schemas.openxmlformats.org/drawingml/2006/main"/>
         </p:blipFill>
         <p:spPr>
-          <a:xfrm xmlns:a="http://schemas.openxmlformats.org/drawingml/2006/main">
+          <a:xfrm xmlns:a="http://schemas.openxmlformats.org/drawingml/2006/main" flipH="0" flipV="0">
             <a:off x="1423988" y="1000125"/>
             <a:ext cx="9344025" cy="5191125"/>
           </a:xfrm>
@@ -7808,6 +7895,7 @@
           <a:lstStyle xmlns:a="http://schemas.openxmlformats.org/drawingml/2006/main"/>
           <a:p xmlns:a="http://schemas.openxmlformats.org/drawingml/2006/main">
             <a:pPr algn="l">
+              <a:buNone/>
               <a:defRPr sz="2903" b="0">
                 <a:solidFill>
                   <a:srgbClr val="000000"/>
@@ -7826,7 +7914,7 @@
                 <a:ea typeface="Helvetica Neue"/>
                 <a:cs typeface="Helvetica Neue"/>
               </a:rPr>
-              <a:t>The rule won only one trade in four—and still had a positive mean trade</a:t>
+              <a:t>Only 23% of fresh crosses won—and the mean trade was barely positive</a:t>
             </a:r>
           </a:p>
         </p:txBody>
@@ -7866,6 +7954,7 @@
           <a:lstStyle xmlns:a="http://schemas.openxmlformats.org/drawingml/2006/main"/>
           <a:p xmlns:a="http://schemas.openxmlformats.org/drawingml/2006/main">
             <a:pPr algn="r">
+              <a:buNone/>
               <a:defRPr sz="998" b="0">
                 <a:solidFill>
                   <a:srgbClr val="000000"/>
@@ -7891,18 +7980,18 @@
       </p:sp>
       <p:pic>
         <p:nvPicPr>
-          <p:cNvPr id="10" name=""/>
+          <p:cNvPr id="12" name=""/>
           <p:cNvPicPr>
             <a:picLocks xmlns:a="http://schemas.openxmlformats.org/drawingml/2006/main" noChangeAspect="1"/>
           </p:cNvPicPr>
           <p:nvPr/>
         </p:nvPicPr>
         <p:blipFill>
-          <a:blip xmlns:r="http://schemas.openxmlformats.org/officeDocument/2006/relationships" xmlns:a="http://schemas.openxmlformats.org/drawingml/2006/main" r:embed="Re9dfcb0f805c40f4"/>
+          <a:blip xmlns:r="http://schemas.openxmlformats.org/officeDocument/2006/relationships" xmlns:a="http://schemas.openxmlformats.org/drawingml/2006/main" r:embed="R0f2fb97d305d43d5"/>
           <a:stretch xmlns:a="http://schemas.openxmlformats.org/drawingml/2006/main"/>
         </p:blipFill>
         <p:spPr>
-          <a:xfrm xmlns:a="http://schemas.openxmlformats.org/drawingml/2006/main">
+          <a:xfrm xmlns:a="http://schemas.openxmlformats.org/drawingml/2006/main" flipH="0" flipV="0">
             <a:off x="390525" y="1465792"/>
             <a:ext cx="7239000" cy="4021667"/>
           </a:xfrm>
@@ -7946,6 +8035,7 @@
           <a:lstStyle xmlns:a="http://schemas.openxmlformats.org/drawingml/2006/main"/>
           <a:p xmlns:a="http://schemas.openxmlformats.org/drawingml/2006/main">
             <a:pPr algn="ctr">
+              <a:buNone/>
               <a:defRPr sz="3750" b="1">
                 <a:solidFill>
                   <a:srgbClr val="C53030"/>
@@ -7964,7 +8054,7 @@
                 <a:ea typeface="Helvetica Neue"/>
                 <a:cs typeface="Helvetica Neue"/>
               </a:rPr>
-              <a:t>25.0%</a:t>
+              <a:t>23.2%</a:t>
             </a:r>
           </a:p>
         </p:txBody>
@@ -8004,6 +8094,7 @@
           <a:lstStyle xmlns:a="http://schemas.openxmlformats.org/drawingml/2006/main"/>
           <a:p xmlns:a="http://schemas.openxmlformats.org/drawingml/2006/main">
             <a:pPr algn="ctr">
+              <a:buNone/>
               <a:defRPr sz="1800" b="1">
                 <a:solidFill>
                   <a:srgbClr val="000000"/>
@@ -8062,6 +8153,7 @@
           <a:lstStyle xmlns:a="http://schemas.openxmlformats.org/drawingml/2006/main"/>
           <a:p xmlns:a="http://schemas.openxmlformats.org/drawingml/2006/main">
             <a:pPr algn="ctr">
+              <a:buNone/>
               <a:defRPr sz="1800" b="0">
                 <a:solidFill>
                   <a:srgbClr val="000000"/>
@@ -8085,6 +8177,7 @@
           </a:p>
           <a:p xmlns:a="http://schemas.openxmlformats.org/drawingml/2006/main">
             <a:pPr algn="ctr">
+              <a:buNone/>
               <a:defRPr sz="1800" b="0">
                 <a:solidFill>
                   <a:srgbClr val="000000"/>
@@ -8103,11 +8196,12 @@
                 <a:ea typeface="Helvetica Neue"/>
                 <a:cs typeface="Helvetica Neue"/>
               </a:rPr>
-              <a:t>+0.86% mean trade</a:t>
+              <a:t>+0.15% mean trade</a:t>
             </a:r>
           </a:p>
           <a:p xmlns:a="http://schemas.openxmlformats.org/drawingml/2006/main">
             <a:pPr algn="ctr">
+              <a:buNone/>
               <a:defRPr sz="1800" b="0">
                 <a:solidFill>
                   <a:srgbClr val="000000"/>
@@ -8126,11 +8220,12 @@
                 <a:ea typeface="Helvetica Neue"/>
                 <a:cs typeface="Helvetica Neue"/>
               </a:rPr>
-              <a:t>5-session median hold</a:t>
+              <a:t>4-session median hold</a:t>
             </a:r>
           </a:p>
           <a:p xmlns:a="http://schemas.openxmlformats.org/drawingml/2006/main">
             <a:pPr algn="ctr">
+              <a:buNone/>
               <a:defRPr sz="1800" b="0">
                 <a:solidFill>
                   <a:srgbClr val="000000"/>
@@ -8149,7 +8244,7 @@
                 <a:ea typeface="Helvetica Neue"/>
                 <a:cs typeface="Helvetica Neue"/>
               </a:rPr>
-              <a:t>71% lasted &lt;=20 sessions</a:t>
+              <a:t>74.7% lasted &lt;=20 sessions</a:t>
             </a:r>
           </a:p>
         </p:txBody>
@@ -8189,6 +8284,7 @@
           <a:lstStyle xmlns:a="http://schemas.openxmlformats.org/drawingml/2006/main"/>
           <a:p xmlns:a="http://schemas.openxmlformats.org/drawingml/2006/main">
             <a:pPr algn="ctr">
+              <a:buNone/>
               <a:defRPr sz="1500" b="0">
                 <a:solidFill>
                   <a:srgbClr val="667085"/>
@@ -8207,7 +8303,7 @@
                 <a:ea typeface="Helvetica Neue"/>
                 <a:cs typeface="Helvetica Neue"/>
               </a:rPr>
-              <a:t>A few long trends paid for many short false starts.</a:t>
+              <a:t>A few longer trends barely offset many short false starts.</a:t>
             </a:r>
           </a:p>
         </p:txBody>
@@ -8269,6 +8365,7 @@
           <a:lstStyle xmlns:a="http://schemas.openxmlformats.org/drawingml/2006/main"/>
           <a:p xmlns:a="http://schemas.openxmlformats.org/drawingml/2006/main">
             <a:pPr algn="l">
+              <a:buNone/>
               <a:defRPr sz="2903" b="0">
                 <a:solidFill>
                   <a:srgbClr val="000000"/>
@@ -8327,6 +8424,7 @@
           <a:lstStyle xmlns:a="http://schemas.openxmlformats.org/drawingml/2006/main"/>
           <a:p xmlns:a="http://schemas.openxmlformats.org/drawingml/2006/main">
             <a:pPr algn="r">
+              <a:buNone/>
               <a:defRPr sz="998" b="0">
                 <a:solidFill>
                   <a:srgbClr val="000000"/>
@@ -8352,18 +8450,18 @@
       </p:sp>
       <p:pic>
         <p:nvPicPr>
-          <p:cNvPr id="6" name=""/>
+          <p:cNvPr id="8" name=""/>
           <p:cNvPicPr>
             <a:picLocks xmlns:a="http://schemas.openxmlformats.org/drawingml/2006/main" noChangeAspect="1"/>
           </p:cNvPicPr>
           <p:nvPr/>
         </p:nvPicPr>
         <p:blipFill>
-          <a:blip xmlns:r="http://schemas.openxmlformats.org/officeDocument/2006/relationships" xmlns:a="http://schemas.openxmlformats.org/drawingml/2006/main" r:embed="R3eb4088bca384355"/>
+          <a:blip xmlns:r="http://schemas.openxmlformats.org/officeDocument/2006/relationships" xmlns:a="http://schemas.openxmlformats.org/drawingml/2006/main" r:embed="R1df4a00f743d4ae7"/>
           <a:stretch xmlns:a="http://schemas.openxmlformats.org/drawingml/2006/main"/>
         </p:blipFill>
         <p:spPr>
-          <a:xfrm xmlns:a="http://schemas.openxmlformats.org/drawingml/2006/main">
+          <a:xfrm xmlns:a="http://schemas.openxmlformats.org/drawingml/2006/main" flipH="0" flipV="0">
             <a:off x="1423988" y="1000125"/>
             <a:ext cx="9344025" cy="5191125"/>
           </a:xfrm>

</xml_diff>